<commit_message>
feat: Add working app screenshots for P03, P04, P06 test cases to README.md and technical slide deck
</commit_message>
<xml_diff>
--- a/Nidan_TechDeck.pptx
+++ b/Nidan_TechDeck.pptx
@@ -14,6 +14,9 @@
     <p:sldId id="262" r:id="rId14"/>
     <p:sldId id="263" r:id="rId15"/>
     <p:sldId id="264" r:id="rId16"/>
+    <p:sldId id="265" r:id="rId17"/>
+    <p:sldId id="266" r:id="rId18"/>
+    <p:sldId id="267" r:id="rId19"/>
   </p:sldIdLst>
   <p:sldSz cx="12188952" cy="6858000" type="screen4x3"/>
   <p:notesSz cx="6858000" cy="9144000"/>
@@ -4889,6 +4892,935 @@
           </a:p>
         </p:txBody>
       </p:sp>
+    </p:spTree>
+  </p:cSld>
+  <p:clrMapOvr>
+    <a:masterClrMapping/>
+  </p:clrMapOvr>
+</p:sld>
+</file>
+
+<file path=ppt/slides/slide10.xml><?xml version="1.0" encoding="utf-8"?>
+<p:sld xmlns:a="http://schemas.openxmlformats.org/drawingml/2006/main" xmlns:p="http://schemas.openxmlformats.org/presentationml/2006/main" xmlns:r="http://schemas.openxmlformats.org/officeDocument/2006/relationships">
+  <p:cSld>
+    <p:bg>
+      <p:bgPr>
+        <a:solidFill>
+          <a:srgbClr val="F8FAFC"/>
+        </a:solidFill>
+        <a:effectLst/>
+      </p:bgPr>
+    </p:bg>
+    <p:spTree>
+      <p:nvGrpSpPr>
+        <p:cNvPr id="1" name=""/>
+        <p:cNvGrpSpPr/>
+        <p:nvPr/>
+      </p:nvGrpSpPr>
+      <p:grpSpPr/>
+      <p:sp>
+        <p:nvSpPr>
+          <p:cNvPr id="2" name="Rectangle 1"/>
+          <p:cNvSpPr/>
+          <p:nvPr/>
+        </p:nvSpPr>
+        <p:spPr>
+          <a:xfrm>
+            <a:off x="0" y="0"/>
+            <a:ext cx="12188952" cy="914400"/>
+          </a:xfrm>
+          <a:prstGeom prst="rect">
+            <a:avLst/>
+          </a:prstGeom>
+          <a:solidFill>
+            <a:srgbClr val="0F172A"/>
+          </a:solidFill>
+          <a:ln>
+            <a:noFill/>
+          </a:ln>
+        </p:spPr>
+        <p:style>
+          <a:lnRef idx="1">
+            <a:schemeClr val="accent1"/>
+          </a:lnRef>
+          <a:fillRef idx="3">
+            <a:schemeClr val="accent1"/>
+          </a:fillRef>
+          <a:effectRef idx="2">
+            <a:schemeClr val="accent1"/>
+          </a:effectRef>
+          <a:fontRef idx="minor">
+            <a:schemeClr val="lt1"/>
+          </a:fontRef>
+        </p:style>
+        <p:txBody>
+          <a:bodyPr rtlCol="0" anchor="ctr"/>
+          <a:lstStyle/>
+          <a:p>
+            <a:pPr algn="ctr"/>
+          </a:p>
+        </p:txBody>
+      </p:sp>
+      <p:sp>
+        <p:nvSpPr>
+          <p:cNvPr id="3" name="TextBox 2"/>
+          <p:cNvSpPr txBox="1"/>
+          <p:nvPr/>
+        </p:nvSpPr>
+        <p:spPr>
+          <a:xfrm>
+            <a:off x="411480" y="201168"/>
+            <a:ext cx="9601200" cy="594360"/>
+          </a:xfrm>
+          <a:prstGeom prst="rect">
+            <a:avLst/>
+          </a:prstGeom>
+          <a:noFill/>
+        </p:spPr>
+        <p:txBody>
+          <a:bodyPr wrap="square">
+            <a:spAutoFit/>
+          </a:bodyPr>
+          <a:lstStyle/>
+          <a:p>
+            <a:pPr algn="l"/>
+            <a:r>
+              <a:rPr sz="2800" b="1" i="0">
+                <a:solidFill>
+                  <a:srgbClr val="FFFFFF"/>
+                </a:solidFill>
+                <a:latin typeface="Calibri"/>
+              </a:rPr>
+              <a:t>Test Case P03: Multi-Condition High Risk</a:t>
+            </a:r>
+          </a:p>
+        </p:txBody>
+      </p:sp>
+      <p:sp>
+        <p:nvSpPr>
+          <p:cNvPr id="4" name="Rectangle 3"/>
+          <p:cNvSpPr/>
+          <p:nvPr/>
+        </p:nvSpPr>
+        <p:spPr>
+          <a:xfrm>
+            <a:off x="11201400" y="256032"/>
+            <a:ext cx="685800" cy="347472"/>
+          </a:xfrm>
+          <a:prstGeom prst="roundRect">
+            <a:avLst>
+              <a:gd name="adj" fmla="val 18000"/>
+            </a:avLst>
+          </a:prstGeom>
+          <a:solidFill>
+            <a:srgbClr val="009688"/>
+          </a:solidFill>
+          <a:ln>
+            <a:noFill/>
+          </a:ln>
+        </p:spPr>
+        <p:style>
+          <a:lnRef idx="1">
+            <a:schemeClr val="accent1"/>
+          </a:lnRef>
+          <a:fillRef idx="3">
+            <a:schemeClr val="accent1"/>
+          </a:fillRef>
+          <a:effectRef idx="2">
+            <a:schemeClr val="accent1"/>
+          </a:effectRef>
+          <a:fontRef idx="minor">
+            <a:schemeClr val="lt1"/>
+          </a:fontRef>
+        </p:style>
+        <p:txBody>
+          <a:bodyPr rtlCol="0" anchor="ctr" wrap="square"/>
+          <a:lstStyle/>
+          <a:p>
+            <a:pPr algn="ctr"/>
+            <a:r>
+              <a:rPr sz="1000" b="1">
+                <a:solidFill>
+                  <a:srgbClr val="FFFFFF"/>
+                </a:solidFill>
+                <a:latin typeface="Calibri"/>
+              </a:rPr>
+              <a:t>  10  </a:t>
+            </a:r>
+          </a:p>
+        </p:txBody>
+      </p:sp>
+      <p:sp>
+        <p:nvSpPr>
+          <p:cNvPr id="5" name="Rectangle 4"/>
+          <p:cNvSpPr/>
+          <p:nvPr/>
+        </p:nvSpPr>
+        <p:spPr>
+          <a:xfrm>
+            <a:off x="320040" y="1051560"/>
+            <a:ext cx="4114800" cy="5349240"/>
+          </a:xfrm>
+          <a:prstGeom prst="rect">
+            <a:avLst/>
+          </a:prstGeom>
+          <a:solidFill>
+            <a:srgbClr val="FFFFFF"/>
+          </a:solidFill>
+          <a:ln w="19050">
+            <a:solidFill>
+              <a:srgbClr val="DC2626"/>
+            </a:solidFill>
+          </a:ln>
+        </p:spPr>
+        <p:style>
+          <a:lnRef idx="1">
+            <a:schemeClr val="accent1"/>
+          </a:lnRef>
+          <a:fillRef idx="3">
+            <a:schemeClr val="accent1"/>
+          </a:fillRef>
+          <a:effectRef idx="2">
+            <a:schemeClr val="accent1"/>
+          </a:effectRef>
+          <a:fontRef idx="minor">
+            <a:schemeClr val="lt1"/>
+          </a:fontRef>
+        </p:style>
+        <p:txBody>
+          <a:bodyPr rtlCol="0" anchor="ctr"/>
+          <a:lstStyle/>
+          <a:p>
+            <a:pPr algn="ctr"/>
+          </a:p>
+        </p:txBody>
+      </p:sp>
+      <p:sp>
+        <p:nvSpPr>
+          <p:cNvPr id="6" name="TextBox 5"/>
+          <p:cNvSpPr txBox="1"/>
+          <p:nvPr/>
+        </p:nvSpPr>
+        <p:spPr>
+          <a:xfrm>
+            <a:off x="502920" y="1188720"/>
+            <a:ext cx="3749039" cy="365760"/>
+          </a:xfrm>
+          <a:prstGeom prst="rect">
+            <a:avLst/>
+          </a:prstGeom>
+          <a:noFill/>
+        </p:spPr>
+        <p:txBody>
+          <a:bodyPr wrap="square">
+            <a:spAutoFit/>
+          </a:bodyPr>
+          <a:lstStyle/>
+          <a:p>
+            <a:pPr algn="l"/>
+            <a:r>
+              <a:rPr sz="1400" b="1" i="0">
+                <a:solidFill>
+                  <a:srgbClr val="0F172A"/>
+                </a:solidFill>
+                <a:latin typeface="Calibri"/>
+              </a:rPr>
+              <a:t>High Risk Scenario Profile</a:t>
+            </a:r>
+          </a:p>
+        </p:txBody>
+      </p:sp>
+      <p:sp>
+        <p:nvSpPr>
+          <p:cNvPr id="7" name="TextBox 6"/>
+          <p:cNvSpPr txBox="1"/>
+          <p:nvPr/>
+        </p:nvSpPr>
+        <p:spPr>
+          <a:xfrm>
+            <a:off x="502920" y="1691640"/>
+            <a:ext cx="3749039" cy="4572000"/>
+          </a:xfrm>
+          <a:prstGeom prst="rect">
+            <a:avLst/>
+          </a:prstGeom>
+          <a:noFill/>
+        </p:spPr>
+        <p:txBody>
+          <a:bodyPr wrap="square">
+            <a:spAutoFit/>
+          </a:bodyPr>
+          <a:lstStyle/>
+          <a:p>
+            <a:pPr algn="l"/>
+            <a:r>
+              <a:rPr sz="1150" b="0" i="0">
+                <a:solidFill>
+                  <a:srgbClr val="334155"/>
+                </a:solidFill>
+                <a:latin typeface="Calibri"/>
+              </a:rPr>
+              <a:t>• Patient features:
+  - Age: 65, Male
+  - Waist: 102cm (IDRS high)
+  - SBP: 165 mmHg (HTN Stage 2)
+  - Lipids: Total Chol 6.2 mmol/L
+  - Creatinine: 1.8 mg/dL
+  - Urine ACR: 45 mg/g (CKD G3b-A2)
+• Assessment Outcomes:
+  - CVD risk: 36% (Very High)
+  - IDRS: 80 (High Risk)
+  - HTN: Stage 2 Hypertension
+  - CKD: Orange (High Risk)
+• Referral Engine:
+  - Action: REFER (Urgent)
+  - Note drafts complete clinical justifications for the PCP.</a:t>
+            </a:r>
+          </a:p>
+        </p:txBody>
+      </p:sp>
+      <p:pic>
+        <p:nvPicPr>
+          <p:cNvPr id="8" name="Picture 7" descr="p03_results.png"/>
+          <p:cNvPicPr>
+            <a:picLocks noChangeAspect="1"/>
+          </p:cNvPicPr>
+          <p:nvPr/>
+        </p:nvPicPr>
+        <p:blipFill>
+          <a:blip r:embed="rId2"/>
+          <a:stretch>
+            <a:fillRect/>
+          </a:stretch>
+        </p:blipFill>
+        <p:spPr>
+          <a:xfrm>
+            <a:off x="4663440" y="1051560"/>
+            <a:ext cx="7132320" cy="5349240"/>
+          </a:xfrm>
+          <a:prstGeom prst="rect">
+            <a:avLst/>
+          </a:prstGeom>
+        </p:spPr>
+      </p:pic>
+    </p:spTree>
+  </p:cSld>
+  <p:clrMapOvr>
+    <a:masterClrMapping/>
+  </p:clrMapOvr>
+</p:sld>
+</file>
+
+<file path=ppt/slides/slide11.xml><?xml version="1.0" encoding="utf-8"?>
+<p:sld xmlns:a="http://schemas.openxmlformats.org/drawingml/2006/main" xmlns:p="http://schemas.openxmlformats.org/presentationml/2006/main" xmlns:r="http://schemas.openxmlformats.org/officeDocument/2006/relationships">
+  <p:cSld>
+    <p:bg>
+      <p:bgPr>
+        <a:solidFill>
+          <a:srgbClr val="F8FAFC"/>
+        </a:solidFill>
+        <a:effectLst/>
+      </p:bgPr>
+    </p:bg>
+    <p:spTree>
+      <p:nvGrpSpPr>
+        <p:cNvPr id="1" name=""/>
+        <p:cNvGrpSpPr/>
+        <p:nvPr/>
+      </p:nvGrpSpPr>
+      <p:grpSpPr/>
+      <p:sp>
+        <p:nvSpPr>
+          <p:cNvPr id="2" name="Rectangle 1"/>
+          <p:cNvSpPr/>
+          <p:nvPr/>
+        </p:nvSpPr>
+        <p:spPr>
+          <a:xfrm>
+            <a:off x="0" y="0"/>
+            <a:ext cx="12188952" cy="914400"/>
+          </a:xfrm>
+          <a:prstGeom prst="rect">
+            <a:avLst/>
+          </a:prstGeom>
+          <a:solidFill>
+            <a:srgbClr val="0F172A"/>
+          </a:solidFill>
+          <a:ln>
+            <a:noFill/>
+          </a:ln>
+        </p:spPr>
+        <p:style>
+          <a:lnRef idx="1">
+            <a:schemeClr val="accent1"/>
+          </a:lnRef>
+          <a:fillRef idx="3">
+            <a:schemeClr val="accent1"/>
+          </a:fillRef>
+          <a:effectRef idx="2">
+            <a:schemeClr val="accent1"/>
+          </a:effectRef>
+          <a:fontRef idx="minor">
+            <a:schemeClr val="lt1"/>
+          </a:fontRef>
+        </p:style>
+        <p:txBody>
+          <a:bodyPr rtlCol="0" anchor="ctr"/>
+          <a:lstStyle/>
+          <a:p>
+            <a:pPr algn="ctr"/>
+          </a:p>
+        </p:txBody>
+      </p:sp>
+      <p:sp>
+        <p:nvSpPr>
+          <p:cNvPr id="3" name="TextBox 2"/>
+          <p:cNvSpPr txBox="1"/>
+          <p:nvPr/>
+        </p:nvSpPr>
+        <p:spPr>
+          <a:xfrm>
+            <a:off x="411480" y="201168"/>
+            <a:ext cx="9601200" cy="594360"/>
+          </a:xfrm>
+          <a:prstGeom prst="rect">
+            <a:avLst/>
+          </a:prstGeom>
+          <a:noFill/>
+        </p:spPr>
+        <p:txBody>
+          <a:bodyPr wrap="square">
+            <a:spAutoFit/>
+          </a:bodyPr>
+          <a:lstStyle/>
+          <a:p>
+            <a:pPr algn="l"/>
+            <a:r>
+              <a:rPr sz="2800" b="1" i="0">
+                <a:solidFill>
+                  <a:srgbClr val="FFFFFF"/>
+                </a:solidFill>
+                <a:latin typeface="Calibri"/>
+              </a:rPr>
+              <a:t>Test Case P04: Missing Labs Fallback</a:t>
+            </a:r>
+          </a:p>
+        </p:txBody>
+      </p:sp>
+      <p:sp>
+        <p:nvSpPr>
+          <p:cNvPr id="4" name="Rectangle 3"/>
+          <p:cNvSpPr/>
+          <p:nvPr/>
+        </p:nvSpPr>
+        <p:spPr>
+          <a:xfrm>
+            <a:off x="11201400" y="256032"/>
+            <a:ext cx="685800" cy="347472"/>
+          </a:xfrm>
+          <a:prstGeom prst="roundRect">
+            <a:avLst>
+              <a:gd name="adj" fmla="val 18000"/>
+            </a:avLst>
+          </a:prstGeom>
+          <a:solidFill>
+            <a:srgbClr val="009688"/>
+          </a:solidFill>
+          <a:ln>
+            <a:noFill/>
+          </a:ln>
+        </p:spPr>
+        <p:style>
+          <a:lnRef idx="1">
+            <a:schemeClr val="accent1"/>
+          </a:lnRef>
+          <a:fillRef idx="3">
+            <a:schemeClr val="accent1"/>
+          </a:fillRef>
+          <a:effectRef idx="2">
+            <a:schemeClr val="accent1"/>
+          </a:effectRef>
+          <a:fontRef idx="minor">
+            <a:schemeClr val="lt1"/>
+          </a:fontRef>
+        </p:style>
+        <p:txBody>
+          <a:bodyPr rtlCol="0" anchor="ctr" wrap="square"/>
+          <a:lstStyle/>
+          <a:p>
+            <a:pPr algn="ctr"/>
+            <a:r>
+              <a:rPr sz="1000" b="1">
+                <a:solidFill>
+                  <a:srgbClr val="FFFFFF"/>
+                </a:solidFill>
+                <a:latin typeface="Calibri"/>
+              </a:rPr>
+              <a:t>  11  </a:t>
+            </a:r>
+          </a:p>
+        </p:txBody>
+      </p:sp>
+      <p:sp>
+        <p:nvSpPr>
+          <p:cNvPr id="5" name="Rectangle 4"/>
+          <p:cNvSpPr/>
+          <p:nvPr/>
+        </p:nvSpPr>
+        <p:spPr>
+          <a:xfrm>
+            <a:off x="320040" y="1051560"/>
+            <a:ext cx="4114800" cy="5349240"/>
+          </a:xfrm>
+          <a:prstGeom prst="rect">
+            <a:avLst/>
+          </a:prstGeom>
+          <a:solidFill>
+            <a:srgbClr val="FFFFFF"/>
+          </a:solidFill>
+          <a:ln w="19050">
+            <a:solidFill>
+              <a:srgbClr val="EA580C"/>
+            </a:solidFill>
+          </a:ln>
+        </p:spPr>
+        <p:style>
+          <a:lnRef idx="1">
+            <a:schemeClr val="accent1"/>
+          </a:lnRef>
+          <a:fillRef idx="3">
+            <a:schemeClr val="accent1"/>
+          </a:fillRef>
+          <a:effectRef idx="2">
+            <a:schemeClr val="accent1"/>
+          </a:effectRef>
+          <a:fontRef idx="minor">
+            <a:schemeClr val="lt1"/>
+          </a:fontRef>
+        </p:style>
+        <p:txBody>
+          <a:bodyPr rtlCol="0" anchor="ctr"/>
+          <a:lstStyle/>
+          <a:p>
+            <a:pPr algn="ctr"/>
+          </a:p>
+        </p:txBody>
+      </p:sp>
+      <p:sp>
+        <p:nvSpPr>
+          <p:cNvPr id="6" name="TextBox 5"/>
+          <p:cNvSpPr txBox="1"/>
+          <p:nvPr/>
+        </p:nvSpPr>
+        <p:spPr>
+          <a:xfrm>
+            <a:off x="502920" y="1188720"/>
+            <a:ext cx="3749039" cy="365760"/>
+          </a:xfrm>
+          <a:prstGeom prst="rect">
+            <a:avLst/>
+          </a:prstGeom>
+          <a:noFill/>
+        </p:spPr>
+        <p:txBody>
+          <a:bodyPr wrap="square">
+            <a:spAutoFit/>
+          </a:bodyPr>
+          <a:lstStyle/>
+          <a:p>
+            <a:pPr algn="l"/>
+            <a:r>
+              <a:rPr sz="1400" b="1" i="0">
+                <a:solidFill>
+                  <a:srgbClr val="0F172A"/>
+                </a:solidFill>
+                <a:latin typeface="Calibri"/>
+              </a:rPr>
+              <a:t>Graceful Degradation Profile</a:t>
+            </a:r>
+          </a:p>
+        </p:txBody>
+      </p:sp>
+      <p:sp>
+        <p:nvSpPr>
+          <p:cNvPr id="7" name="TextBox 6"/>
+          <p:cNvSpPr txBox="1"/>
+          <p:nvPr/>
+        </p:nvSpPr>
+        <p:spPr>
+          <a:xfrm>
+            <a:off x="502920" y="1691640"/>
+            <a:ext cx="3749039" cy="4572000"/>
+          </a:xfrm>
+          <a:prstGeom prst="rect">
+            <a:avLst/>
+          </a:prstGeom>
+          <a:noFill/>
+        </p:spPr>
+        <p:txBody>
+          <a:bodyPr wrap="square">
+            <a:spAutoFit/>
+          </a:bodyPr>
+          <a:lstStyle/>
+          <a:p>
+            <a:pPr algn="l"/>
+            <a:r>
+              <a:rPr sz="1150" b="0" i="0">
+                <a:solidFill>
+                  <a:srgbClr val="334155"/>
+                </a:solidFill>
+                <a:latin typeface="Calibri"/>
+              </a:rPr>
+              <a:t>• Patient features:
+  - Age: 55, Female
+  - Waist: 95cm
+  - SBP: 135 mmHg
+  - Lipids: MISSING (No labs)
+  - BMI: 28.5 (Fallback input)
+• Assessment Outcomes:
+  - CVD: Automatically uses BMI non-lab chart. Calculated risk: 8%.
+  - HTN: Stage 1 Hypertension
+• Required Investigations:
+  - Aggregator flags Lipid Panel and Serum Creatinine as missing.
+  - Cites exact medical source.</a:t>
+            </a:r>
+          </a:p>
+        </p:txBody>
+      </p:sp>
+      <p:pic>
+        <p:nvPicPr>
+          <p:cNvPr id="8" name="Picture 7" descr="p04_results.png"/>
+          <p:cNvPicPr>
+            <a:picLocks noChangeAspect="1"/>
+          </p:cNvPicPr>
+          <p:nvPr/>
+        </p:nvPicPr>
+        <p:blipFill>
+          <a:blip r:embed="rId2"/>
+          <a:stretch>
+            <a:fillRect/>
+          </a:stretch>
+        </p:blipFill>
+        <p:spPr>
+          <a:xfrm>
+            <a:off x="4663440" y="1051560"/>
+            <a:ext cx="7132320" cy="5349240"/>
+          </a:xfrm>
+          <a:prstGeom prst="rect">
+            <a:avLst/>
+          </a:prstGeom>
+        </p:spPr>
+      </p:pic>
+    </p:spTree>
+  </p:cSld>
+  <p:clrMapOvr>
+    <a:masterClrMapping/>
+  </p:clrMapOvr>
+</p:sld>
+</file>
+
+<file path=ppt/slides/slide12.xml><?xml version="1.0" encoding="utf-8"?>
+<p:sld xmlns:a="http://schemas.openxmlformats.org/drawingml/2006/main" xmlns:p="http://schemas.openxmlformats.org/presentationml/2006/main" xmlns:r="http://schemas.openxmlformats.org/officeDocument/2006/relationships">
+  <p:cSld>
+    <p:bg>
+      <p:bgPr>
+        <a:solidFill>
+          <a:srgbClr val="F8FAFC"/>
+        </a:solidFill>
+        <a:effectLst/>
+      </p:bgPr>
+    </p:bg>
+    <p:spTree>
+      <p:nvGrpSpPr>
+        <p:cNvPr id="1" name=""/>
+        <p:cNvGrpSpPr/>
+        <p:nvPr/>
+      </p:nvGrpSpPr>
+      <p:grpSpPr/>
+      <p:sp>
+        <p:nvSpPr>
+          <p:cNvPr id="2" name="Rectangle 1"/>
+          <p:cNvSpPr/>
+          <p:nvPr/>
+        </p:nvSpPr>
+        <p:spPr>
+          <a:xfrm>
+            <a:off x="0" y="0"/>
+            <a:ext cx="12188952" cy="914400"/>
+          </a:xfrm>
+          <a:prstGeom prst="rect">
+            <a:avLst/>
+          </a:prstGeom>
+          <a:solidFill>
+            <a:srgbClr val="0F172A"/>
+          </a:solidFill>
+          <a:ln>
+            <a:noFill/>
+          </a:ln>
+        </p:spPr>
+        <p:style>
+          <a:lnRef idx="1">
+            <a:schemeClr val="accent1"/>
+          </a:lnRef>
+          <a:fillRef idx="3">
+            <a:schemeClr val="accent1"/>
+          </a:fillRef>
+          <a:effectRef idx="2">
+            <a:schemeClr val="accent1"/>
+          </a:effectRef>
+          <a:fontRef idx="minor">
+            <a:schemeClr val="lt1"/>
+          </a:fontRef>
+        </p:style>
+        <p:txBody>
+          <a:bodyPr rtlCol="0" anchor="ctr"/>
+          <a:lstStyle/>
+          <a:p>
+            <a:pPr algn="ctr"/>
+          </a:p>
+        </p:txBody>
+      </p:sp>
+      <p:sp>
+        <p:nvSpPr>
+          <p:cNvPr id="3" name="TextBox 2"/>
+          <p:cNvSpPr txBox="1"/>
+          <p:nvPr/>
+        </p:nvSpPr>
+        <p:spPr>
+          <a:xfrm>
+            <a:off x="411480" y="201168"/>
+            <a:ext cx="9601200" cy="594360"/>
+          </a:xfrm>
+          <a:prstGeom prst="rect">
+            <a:avLst/>
+          </a:prstGeom>
+          <a:noFill/>
+        </p:spPr>
+        <p:txBody>
+          <a:bodyPr wrap="square">
+            <a:spAutoFit/>
+          </a:bodyPr>
+          <a:lstStyle/>
+          <a:p>
+            <a:pPr algn="l"/>
+            <a:r>
+              <a:rPr sz="2800" b="1" i="0">
+                <a:solidFill>
+                  <a:srgbClr val="FFFFFF"/>
+                </a:solidFill>
+                <a:latin typeface="Calibri"/>
+              </a:rPr>
+              <a:t>Test Case P06: Healthy Baseline</a:t>
+            </a:r>
+          </a:p>
+        </p:txBody>
+      </p:sp>
+      <p:sp>
+        <p:nvSpPr>
+          <p:cNvPr id="4" name="Rectangle 3"/>
+          <p:cNvSpPr/>
+          <p:nvPr/>
+        </p:nvSpPr>
+        <p:spPr>
+          <a:xfrm>
+            <a:off x="11201400" y="256032"/>
+            <a:ext cx="685800" cy="347472"/>
+          </a:xfrm>
+          <a:prstGeom prst="roundRect">
+            <a:avLst>
+              <a:gd name="adj" fmla="val 18000"/>
+            </a:avLst>
+          </a:prstGeom>
+          <a:solidFill>
+            <a:srgbClr val="009688"/>
+          </a:solidFill>
+          <a:ln>
+            <a:noFill/>
+          </a:ln>
+        </p:spPr>
+        <p:style>
+          <a:lnRef idx="1">
+            <a:schemeClr val="accent1"/>
+          </a:lnRef>
+          <a:fillRef idx="3">
+            <a:schemeClr val="accent1"/>
+          </a:fillRef>
+          <a:effectRef idx="2">
+            <a:schemeClr val="accent1"/>
+          </a:effectRef>
+          <a:fontRef idx="minor">
+            <a:schemeClr val="lt1"/>
+          </a:fontRef>
+        </p:style>
+        <p:txBody>
+          <a:bodyPr rtlCol="0" anchor="ctr" wrap="square"/>
+          <a:lstStyle/>
+          <a:p>
+            <a:pPr algn="ctr"/>
+            <a:r>
+              <a:rPr sz="1000" b="1">
+                <a:solidFill>
+                  <a:srgbClr val="FFFFFF"/>
+                </a:solidFill>
+                <a:latin typeface="Calibri"/>
+              </a:rPr>
+              <a:t>  12  </a:t>
+            </a:r>
+          </a:p>
+        </p:txBody>
+      </p:sp>
+      <p:sp>
+        <p:nvSpPr>
+          <p:cNvPr id="5" name="Rectangle 4"/>
+          <p:cNvSpPr/>
+          <p:nvPr/>
+        </p:nvSpPr>
+        <p:spPr>
+          <a:xfrm>
+            <a:off x="320040" y="1051560"/>
+            <a:ext cx="4114800" cy="5349240"/>
+          </a:xfrm>
+          <a:prstGeom prst="rect">
+            <a:avLst/>
+          </a:prstGeom>
+          <a:solidFill>
+            <a:srgbClr val="FFFFFF"/>
+          </a:solidFill>
+          <a:ln w="19050">
+            <a:solidFill>
+              <a:srgbClr val="16A34A"/>
+            </a:solidFill>
+          </a:ln>
+        </p:spPr>
+        <p:style>
+          <a:lnRef idx="1">
+            <a:schemeClr val="accent1"/>
+          </a:lnRef>
+          <a:fillRef idx="3">
+            <a:schemeClr val="accent1"/>
+          </a:fillRef>
+          <a:effectRef idx="2">
+            <a:schemeClr val="accent1"/>
+          </a:effectRef>
+          <a:fontRef idx="minor">
+            <a:schemeClr val="lt1"/>
+          </a:fontRef>
+        </p:style>
+        <p:txBody>
+          <a:bodyPr rtlCol="0" anchor="ctr"/>
+          <a:lstStyle/>
+          <a:p>
+            <a:pPr algn="ctr"/>
+          </a:p>
+        </p:txBody>
+      </p:sp>
+      <p:sp>
+        <p:nvSpPr>
+          <p:cNvPr id="6" name="TextBox 5"/>
+          <p:cNvSpPr txBox="1"/>
+          <p:nvPr/>
+        </p:nvSpPr>
+        <p:spPr>
+          <a:xfrm>
+            <a:off x="502920" y="1188720"/>
+            <a:ext cx="3749039" cy="365760"/>
+          </a:xfrm>
+          <a:prstGeom prst="rect">
+            <a:avLst/>
+          </a:prstGeom>
+          <a:noFill/>
+        </p:spPr>
+        <p:txBody>
+          <a:bodyPr wrap="square">
+            <a:spAutoFit/>
+          </a:bodyPr>
+          <a:lstStyle/>
+          <a:p>
+            <a:pPr algn="l"/>
+            <a:r>
+              <a:rPr sz="1400" b="1" i="0">
+                <a:solidFill>
+                  <a:srgbClr val="0F172A"/>
+                </a:solidFill>
+                <a:latin typeface="Calibri"/>
+              </a:rPr>
+              <a:t>Healthy Patient Profile</a:t>
+            </a:r>
+          </a:p>
+        </p:txBody>
+      </p:sp>
+      <p:sp>
+        <p:nvSpPr>
+          <p:cNvPr id="7" name="TextBox 6"/>
+          <p:cNvSpPr txBox="1"/>
+          <p:nvPr/>
+        </p:nvSpPr>
+        <p:spPr>
+          <a:xfrm>
+            <a:off x="502920" y="1691640"/>
+            <a:ext cx="3749039" cy="4572000"/>
+          </a:xfrm>
+          <a:prstGeom prst="rect">
+            <a:avLst/>
+          </a:prstGeom>
+          <a:noFill/>
+        </p:spPr>
+        <p:txBody>
+          <a:bodyPr wrap="square">
+            <a:spAutoFit/>
+          </a:bodyPr>
+          <a:lstStyle/>
+          <a:p>
+            <a:pPr algn="l"/>
+            <a:r>
+              <a:rPr sz="1150" b="0" i="0">
+                <a:solidFill>
+                  <a:srgbClr val="334155"/>
+                </a:solidFill>
+                <a:latin typeface="Calibri"/>
+              </a:rPr>
+              <a:t>• Patient features:
+  - Age: 35, Female
+  - Waist: 70cm
+  - Physical activity: Active
+  - SBP: 110, DBP: 75 mmHg
+  - No prior history
+• Assessment Outcomes:
+  - CVD risk: &lt;1% (Low)
+  - IDRS: 0 (Low)
+  - HTN: Normal BP
+  - CKD: G1/A1 Green (Normal)
+• Referral Engine:
+  - Action: ROUTINE MONITORING
+  - Reassuring clinical communication in summary.</a:t>
+            </a:r>
+          </a:p>
+        </p:txBody>
+      </p:sp>
+      <p:pic>
+        <p:nvPicPr>
+          <p:cNvPr id="8" name="Picture 7" descr="p06_results.png"/>
+          <p:cNvPicPr>
+            <a:picLocks noChangeAspect="1"/>
+          </p:cNvPicPr>
+          <p:nvPr/>
+        </p:nvPicPr>
+        <p:blipFill>
+          <a:blip r:embed="rId2"/>
+          <a:stretch>
+            <a:fillRect/>
+          </a:stretch>
+        </p:blipFill>
+        <p:spPr>
+          <a:xfrm>
+            <a:off x="4663440" y="1051560"/>
+            <a:ext cx="7132320" cy="5349240"/>
+          </a:xfrm>
+          <a:prstGeom prst="rect">
+            <a:avLst/>
+          </a:prstGeom>
+        </p:spPr>
+      </p:pic>
     </p:spTree>
   </p:cSld>
   <p:clrMapOvr>

</xml_diff>